<commit_message>
docs: add fade transitions to slides in Power BI presentation deck
</commit_message>
<xml_diff>
--- a/Bus Booking Analytics System (PowerBI)/documents/Bus_Booking_Analytics_PowerBI.pptx
+++ b/Bus Booking Analytics System (PowerBI)/documents/Bus_Booking_Analytics_PowerBI.pptx
@@ -3188,6 +3188,18 @@
       </p:sp>
     </p:spTree>
   </p:cSld>
+  <mc:AlternateContent xmlns:mc="http://schemas.openxmlformats.org/markup-compatibility/2006">
+    <mc:Choice xmlns:p14="http://schemas.microsoft.com/office/powerpoint/2010/main" Requires="p14">
+      <p:transition spd="slow">
+        <p:fade/>
+      </p:transition>
+    </mc:Choice>
+    <mc:Fallback>
+      <p:transition spd="slow">
+        <p:fade/>
+      </p:transition>
+    </mc:Fallback>
+  </mc:AlternateContent>
   <p:clrMapOvr>
     <a:masterClrMapping/>
   </p:clrMapOvr>
@@ -3634,6 +3646,18 @@
       </p:sp>
     </p:spTree>
   </p:cSld>
+  <mc:AlternateContent xmlns:mc="http://schemas.openxmlformats.org/markup-compatibility/2006">
+    <mc:Choice xmlns:p14="http://schemas.microsoft.com/office/powerpoint/2010/main" Requires="p14">
+      <p:transition spd="slow">
+        <p:fade/>
+      </p:transition>
+    </mc:Choice>
+    <mc:Fallback>
+      <p:transition spd="slow">
+        <p:fade/>
+      </p:transition>
+    </mc:Fallback>
+  </mc:AlternateContent>
   <p:clrMapOvr>
     <a:masterClrMapping/>
   </p:clrMapOvr>
@@ -4080,6 +4104,18 @@
       </p:sp>
     </p:spTree>
   </p:cSld>
+  <mc:AlternateContent xmlns:mc="http://schemas.openxmlformats.org/markup-compatibility/2006">
+    <mc:Choice xmlns:p14="http://schemas.microsoft.com/office/powerpoint/2010/main" Requires="p14">
+      <p:transition spd="slow">
+        <p:fade/>
+      </p:transition>
+    </mc:Choice>
+    <mc:Fallback>
+      <p:transition spd="slow">
+        <p:fade/>
+      </p:transition>
+    </mc:Fallback>
+  </mc:AlternateContent>
   <p:clrMapOvr>
     <a:masterClrMapping/>
   </p:clrMapOvr>
@@ -4526,6 +4562,18 @@
       </p:sp>
     </p:spTree>
   </p:cSld>
+  <mc:AlternateContent xmlns:mc="http://schemas.openxmlformats.org/markup-compatibility/2006">
+    <mc:Choice xmlns:p14="http://schemas.microsoft.com/office/powerpoint/2010/main" Requires="p14">
+      <p:transition spd="slow">
+        <p:fade/>
+      </p:transition>
+    </mc:Choice>
+    <mc:Fallback>
+      <p:transition spd="slow">
+        <p:fade/>
+      </p:transition>
+    </mc:Fallback>
+  </mc:AlternateContent>
   <p:clrMapOvr>
     <a:masterClrMapping/>
   </p:clrMapOvr>
@@ -4972,6 +5020,18 @@
       </p:sp>
     </p:spTree>
   </p:cSld>
+  <mc:AlternateContent xmlns:mc="http://schemas.openxmlformats.org/markup-compatibility/2006">
+    <mc:Choice xmlns:p14="http://schemas.microsoft.com/office/powerpoint/2010/main" Requires="p14">
+      <p:transition spd="slow">
+        <p:fade/>
+      </p:transition>
+    </mc:Choice>
+    <mc:Fallback>
+      <p:transition spd="slow">
+        <p:fade/>
+      </p:transition>
+    </mc:Fallback>
+  </mc:AlternateContent>
   <p:clrMapOvr>
     <a:masterClrMapping/>
   </p:clrMapOvr>
@@ -5418,6 +5478,18 @@
       </p:sp>
     </p:spTree>
   </p:cSld>
+  <mc:AlternateContent xmlns:mc="http://schemas.openxmlformats.org/markup-compatibility/2006">
+    <mc:Choice xmlns:p14="http://schemas.microsoft.com/office/powerpoint/2010/main" Requires="p14">
+      <p:transition spd="slow">
+        <p:fade/>
+      </p:transition>
+    </mc:Choice>
+    <mc:Fallback>
+      <p:transition spd="slow">
+        <p:fade/>
+      </p:transition>
+    </mc:Fallback>
+  </mc:AlternateContent>
   <p:clrMapOvr>
     <a:masterClrMapping/>
   </p:clrMapOvr>
@@ -5789,6 +5861,18 @@
       </p:sp>
     </p:spTree>
   </p:cSld>
+  <mc:AlternateContent xmlns:mc="http://schemas.openxmlformats.org/markup-compatibility/2006">
+    <mc:Choice xmlns:p14="http://schemas.microsoft.com/office/powerpoint/2010/main" Requires="p14">
+      <p:transition spd="slow">
+        <p:fade/>
+      </p:transition>
+    </mc:Choice>
+    <mc:Fallback>
+      <p:transition spd="slow">
+        <p:fade/>
+      </p:transition>
+    </mc:Fallback>
+  </mc:AlternateContent>
   <p:clrMapOvr>
     <a:masterClrMapping/>
   </p:clrMapOvr>

</xml_diff>